<commit_message>
chore: the pitch deck goes light
Same ten slides, same content, paper instead of black.

The product is dark and the deck no longer matches it, deliberately. These are
shown on a projector in a lit hall, where a dark slide becomes a grey rectangle
and a room of people squint at it. The ember accent stays, because that is the
thing the deck and the app actually share, and the screenshots keep their own
dark chrome — against paper they read as a phone held up rather than as a hole
punched in the page.

Two things the dark version got for free and this one has to earn: a tinted card
is nearly invisible on white, so cards now carry a hairline edge, and the same
goes for the screenshots. The ember and the green were both darkened to clear
4.5:1 against paper; on black they were light enough already.
</commit_message>
<xml_diff>
--- a/ClashFit.pptx
+++ b/ClashFit.pptx
@@ -3112,7 +3112,7 @@
             <a:avLst/>
           </a:prstGeom>
           <a:solidFill>
-            <a:srgbClr val="0E0F12"/>
+            <a:srgbClr val="FAF9F7"/>
           </a:solidFill>
           <a:ln>
             <a:noFill/>
@@ -3171,7 +3171,7 @@
             <a:r>
               <a:rPr sz="7600" b="1">
                 <a:solidFill>
-                  <a:srgbClr val="F5F2EC"/>
+                  <a:srgbClr val="14161A"/>
                 </a:solidFill>
                 <a:latin typeface="Verdana"/>
               </a:rPr>
@@ -3210,7 +3210,7 @@
             <a:r>
               <a:rPr sz="2600" b="0">
                 <a:solidFill>
-                  <a:srgbClr val="FF5A2C"/>
+                  <a:srgbClr val="E04418"/>
                 </a:solidFill>
                 <a:latin typeface="Verdana"/>
               </a:rPr>
@@ -3226,7 +3226,7 @@
             <a:r>
               <a:rPr sz="2600" b="0">
                 <a:solidFill>
-                  <a:srgbClr val="FF5A2C"/>
+                  <a:srgbClr val="E04418"/>
                 </a:solidFill>
                 <a:latin typeface="Verdana"/>
               </a:rPr>
@@ -3265,7 +3265,7 @@
             <a:r>
               <a:rPr sz="1400" b="0">
                 <a:solidFill>
-                  <a:srgbClr val="A8A59F"/>
+                  <a:srgbClr val="51565D"/>
                 </a:solidFill>
                 <a:latin typeface="Verdana"/>
               </a:rPr>
@@ -3281,7 +3281,7 @@
             <a:r>
               <a:rPr sz="1400" b="0">
                 <a:solidFill>
-                  <a:srgbClr val="A8A59F"/>
+                  <a:srgbClr val="51565D"/>
                 </a:solidFill>
                 <a:latin typeface="Verdana"/>
               </a:rPr>
@@ -3320,7 +3320,7 @@
             <a:r>
               <a:rPr sz="1100" b="0">
                 <a:solidFill>
-                  <a:srgbClr val="777571"/>
+                  <a:srgbClr val="7C8188"/>
                 </a:solidFill>
                 <a:latin typeface="Verdana"/>
               </a:rPr>
@@ -3351,6 +3351,11 @@
           <a:prstGeom prst="rect">
             <a:avLst/>
           </a:prstGeom>
+          <a:ln w="9525">
+            <a:solidFill>
+              <a:srgbClr val="C8C4BD"/>
+            </a:solidFill>
+          </a:ln>
         </p:spPr>
       </p:pic>
     </p:spTree>
@@ -3386,7 +3391,7 @@
             <a:avLst/>
           </a:prstGeom>
           <a:solidFill>
-            <a:srgbClr val="0E0F12"/>
+            <a:srgbClr val="FAF9F7"/>
           </a:solidFill>
           <a:ln>
             <a:noFill/>
@@ -3445,7 +3450,7 @@
             <a:r>
               <a:rPr sz="1100" b="1">
                 <a:solidFill>
-                  <a:srgbClr val="FF5A2C"/>
+                  <a:srgbClr val="E04418"/>
                 </a:solidFill>
                 <a:latin typeface="Verdana"/>
               </a:rPr>
@@ -3484,7 +3489,7 @@
             <a:r>
               <a:rPr sz="3800" b="1">
                 <a:solidFill>
-                  <a:srgbClr val="F5F2EC"/>
+                  <a:srgbClr val="14161A"/>
                 </a:solidFill>
                 <a:latin typeface="Verdana"/>
               </a:rPr>
@@ -3510,10 +3515,12 @@
             </a:avLst>
           </a:prstGeom>
           <a:solidFill>
-            <a:srgbClr val="1B1C21"/>
+            <a:srgbClr val="F0EEEA"/>
           </a:solidFill>
-          <a:ln>
-            <a:noFill/>
+          <a:ln w="12700">
+            <a:solidFill>
+              <a:srgbClr val="DDD9D2"/>
+            </a:solidFill>
           </a:ln>
           <a:effectLst/>
         </p:spPr>
@@ -3569,7 +3576,7 @@
             <a:r>
               <a:rPr sz="1300" b="1">
                 <a:solidFill>
-                  <a:srgbClr val="FF5A2C"/>
+                  <a:srgbClr val="E04418"/>
                 </a:solidFill>
                 <a:latin typeface="Verdana"/>
               </a:rPr>
@@ -3608,7 +3615,7 @@
             <a:r>
               <a:rPr sz="1150" b="0">
                 <a:solidFill>
-                  <a:srgbClr val="A8A59F"/>
+                  <a:srgbClr val="51565D"/>
                 </a:solidFill>
                 <a:latin typeface="Verdana"/>
               </a:rPr>
@@ -3634,10 +3641,12 @@
             </a:avLst>
           </a:prstGeom>
           <a:solidFill>
-            <a:srgbClr val="1B1C21"/>
+            <a:srgbClr val="F0EEEA"/>
           </a:solidFill>
-          <a:ln>
-            <a:noFill/>
+          <a:ln w="12700">
+            <a:solidFill>
+              <a:srgbClr val="DDD9D2"/>
+            </a:solidFill>
           </a:ln>
           <a:effectLst/>
         </p:spPr>
@@ -3693,7 +3702,7 @@
             <a:r>
               <a:rPr sz="1300" b="1">
                 <a:solidFill>
-                  <a:srgbClr val="FF5A2C"/>
+                  <a:srgbClr val="E04418"/>
                 </a:solidFill>
                 <a:latin typeface="Verdana"/>
               </a:rPr>
@@ -3732,7 +3741,7 @@
             <a:r>
               <a:rPr sz="1150" b="0">
                 <a:solidFill>
-                  <a:srgbClr val="A8A59F"/>
+                  <a:srgbClr val="51565D"/>
                 </a:solidFill>
                 <a:latin typeface="Verdana"/>
               </a:rPr>
@@ -3758,10 +3767,12 @@
             </a:avLst>
           </a:prstGeom>
           <a:solidFill>
-            <a:srgbClr val="1B1C21"/>
+            <a:srgbClr val="F0EEEA"/>
           </a:solidFill>
-          <a:ln>
-            <a:noFill/>
+          <a:ln w="12700">
+            <a:solidFill>
+              <a:srgbClr val="DDD9D2"/>
+            </a:solidFill>
           </a:ln>
           <a:effectLst/>
         </p:spPr>
@@ -3817,7 +3828,7 @@
             <a:r>
               <a:rPr sz="1300" b="1">
                 <a:solidFill>
-                  <a:srgbClr val="FF5A2C"/>
+                  <a:srgbClr val="E04418"/>
                 </a:solidFill>
                 <a:latin typeface="Verdana"/>
               </a:rPr>
@@ -3856,7 +3867,7 @@
             <a:r>
               <a:rPr sz="1150" b="0">
                 <a:solidFill>
-                  <a:srgbClr val="A8A59F"/>
+                  <a:srgbClr val="51565D"/>
                 </a:solidFill>
                 <a:latin typeface="Verdana"/>
               </a:rPr>
@@ -3882,10 +3893,12 @@
             </a:avLst>
           </a:prstGeom>
           <a:solidFill>
-            <a:srgbClr val="1B1C21"/>
+            <a:srgbClr val="F0EEEA"/>
           </a:solidFill>
-          <a:ln>
-            <a:noFill/>
+          <a:ln w="12700">
+            <a:solidFill>
+              <a:srgbClr val="DDD9D2"/>
+            </a:solidFill>
           </a:ln>
           <a:effectLst/>
         </p:spPr>
@@ -3941,7 +3954,7 @@
             <a:r>
               <a:rPr sz="1300" b="1">
                 <a:solidFill>
-                  <a:srgbClr val="FF5A2C"/>
+                  <a:srgbClr val="E04418"/>
                 </a:solidFill>
                 <a:latin typeface="Verdana"/>
               </a:rPr>
@@ -3980,7 +3993,7 @@
             <a:r>
               <a:rPr sz="1150" b="0">
                 <a:solidFill>
-                  <a:srgbClr val="A8A59F"/>
+                  <a:srgbClr val="51565D"/>
                 </a:solidFill>
                 <a:latin typeface="Verdana"/>
               </a:rPr>
@@ -4006,10 +4019,12 @@
             </a:avLst>
           </a:prstGeom>
           <a:solidFill>
-            <a:srgbClr val="1B1C21"/>
+            <a:srgbClr val="F0EEEA"/>
           </a:solidFill>
-          <a:ln>
-            <a:noFill/>
+          <a:ln w="12700">
+            <a:solidFill>
+              <a:srgbClr val="DDD9D2"/>
+            </a:solidFill>
           </a:ln>
           <a:effectLst/>
         </p:spPr>
@@ -4065,7 +4080,7 @@
             <a:r>
               <a:rPr sz="1300" b="1">
                 <a:solidFill>
-                  <a:srgbClr val="FF5A2C"/>
+                  <a:srgbClr val="E04418"/>
                 </a:solidFill>
                 <a:latin typeface="Verdana"/>
               </a:rPr>
@@ -4104,7 +4119,7 @@
             <a:r>
               <a:rPr sz="1150" b="0">
                 <a:solidFill>
-                  <a:srgbClr val="A8A59F"/>
+                  <a:srgbClr val="51565D"/>
                 </a:solidFill>
                 <a:latin typeface="Verdana"/>
               </a:rPr>
@@ -4143,7 +4158,7 @@
             <a:r>
               <a:rPr sz="1500" b="0">
                 <a:solidFill>
-                  <a:srgbClr val="F5F2EC"/>
+                  <a:srgbClr val="14161A"/>
                 </a:solidFill>
                 <a:latin typeface="Verdana"/>
               </a:rPr>
@@ -4185,7 +4200,7 @@
             <a:avLst/>
           </a:prstGeom>
           <a:solidFill>
-            <a:srgbClr val="0E0F12"/>
+            <a:srgbClr val="FAF9F7"/>
           </a:solidFill>
           <a:ln>
             <a:noFill/>
@@ -4244,7 +4259,7 @@
             <a:r>
               <a:rPr sz="1100" b="1">
                 <a:solidFill>
-                  <a:srgbClr val="FF5A2C"/>
+                  <a:srgbClr val="E04418"/>
                 </a:solidFill>
                 <a:latin typeface="Verdana"/>
               </a:rPr>
@@ -4283,7 +4298,7 @@
             <a:r>
               <a:rPr sz="4400" b="1">
                 <a:solidFill>
-                  <a:srgbClr val="F5F2EC"/>
+                  <a:srgbClr val="14161A"/>
                 </a:solidFill>
                 <a:latin typeface="Verdana"/>
               </a:rPr>
@@ -4322,7 +4337,7 @@
             <a:r>
               <a:rPr sz="1600" b="0">
                 <a:solidFill>
-                  <a:srgbClr val="A8A59F"/>
+                  <a:srgbClr val="51565D"/>
                 </a:solidFill>
                 <a:latin typeface="Verdana"/>
               </a:rPr>
@@ -4338,7 +4353,7 @@
             <a:r>
               <a:rPr sz="1600" b="0">
                 <a:solidFill>
-                  <a:srgbClr val="A8A59F"/>
+                  <a:srgbClr val="51565D"/>
                 </a:solidFill>
                 <a:latin typeface="Verdana"/>
               </a:rPr>
@@ -4354,7 +4369,7 @@
             <a:r>
               <a:rPr sz="1600" b="0">
                 <a:solidFill>
-                  <a:srgbClr val="A8A59F"/>
+                  <a:srgbClr val="51565D"/>
                 </a:solidFill>
                 <a:latin typeface="Verdana"/>
               </a:rPr>
@@ -4380,10 +4395,12 @@
             </a:avLst>
           </a:prstGeom>
           <a:solidFill>
-            <a:srgbClr val="1B1C21"/>
+            <a:srgbClr val="F0EEEA"/>
           </a:solidFill>
-          <a:ln>
-            <a:noFill/>
+          <a:ln w="12700">
+            <a:solidFill>
+              <a:srgbClr val="DDD9D2"/>
+            </a:solidFill>
           </a:ln>
           <a:effectLst/>
         </p:spPr>
@@ -4439,7 +4456,7 @@
             <a:r>
               <a:rPr sz="1900" b="0">
                 <a:solidFill>
-                  <a:srgbClr val="F5F2EC"/>
+                  <a:srgbClr val="14161A"/>
                 </a:solidFill>
                 <a:latin typeface="Verdana"/>
               </a:rPr>
@@ -4455,7 +4472,7 @@
             <a:r>
               <a:rPr sz="1900" b="0">
                 <a:solidFill>
-                  <a:srgbClr val="F5F2EC"/>
+                  <a:srgbClr val="14161A"/>
                 </a:solidFill>
                 <a:latin typeface="Verdana"/>
               </a:rPr>
@@ -4471,7 +4488,7 @@
             <a:r>
               <a:rPr sz="1900" b="0">
                 <a:solidFill>
-                  <a:srgbClr val="F5F2EC"/>
+                  <a:srgbClr val="14161A"/>
                 </a:solidFill>
                 <a:latin typeface="Verdana"/>
               </a:rPr>
@@ -4487,7 +4504,7 @@
             <a:r>
               <a:rPr sz="1900" b="0">
                 <a:solidFill>
-                  <a:srgbClr val="F5F2EC"/>
+                  <a:srgbClr val="14161A"/>
                 </a:solidFill>
                 <a:latin typeface="Verdana"/>
               </a:rPr>
@@ -4503,7 +4520,7 @@
             <a:r>
               <a:rPr sz="1900" b="0">
                 <a:solidFill>
-                  <a:srgbClr val="F5F2EC"/>
+                  <a:srgbClr val="14161A"/>
                 </a:solidFill>
                 <a:latin typeface="Verdana"/>
               </a:rPr>
@@ -4542,7 +4559,7 @@
             <a:r>
               <a:rPr sz="1600" b="0">
                 <a:solidFill>
-                  <a:srgbClr val="FF5A2C"/>
+                  <a:srgbClr val="E04418"/>
                 </a:solidFill>
                 <a:latin typeface="Verdana"/>
               </a:rPr>
@@ -4584,7 +4601,7 @@
             <a:avLst/>
           </a:prstGeom>
           <a:solidFill>
-            <a:srgbClr val="0E0F12"/>
+            <a:srgbClr val="FAF9F7"/>
           </a:solidFill>
           <a:ln>
             <a:noFill/>
@@ -4643,7 +4660,7 @@
             <a:r>
               <a:rPr sz="1100" b="1">
                 <a:solidFill>
-                  <a:srgbClr val="FF5A2C"/>
+                  <a:srgbClr val="E04418"/>
                 </a:solidFill>
                 <a:latin typeface="Verdana"/>
               </a:rPr>
@@ -4682,7 +4699,7 @@
             <a:r>
               <a:rPr sz="3600" b="1">
                 <a:solidFill>
-                  <a:srgbClr val="F5F2EC"/>
+                  <a:srgbClr val="14161A"/>
                 </a:solidFill>
                 <a:latin typeface="Verdana"/>
               </a:rPr>
@@ -4713,6 +4730,11 @@
           <a:prstGeom prst="rect">
             <a:avLst/>
           </a:prstGeom>
+          <a:ln w="9525">
+            <a:solidFill>
+              <a:srgbClr val="C8C4BD"/>
+            </a:solidFill>
+          </a:ln>
         </p:spPr>
       </p:pic>
       <p:sp>
@@ -4745,7 +4767,7 @@
             <a:r>
               <a:rPr sz="1000" b="0">
                 <a:solidFill>
-                  <a:srgbClr val="A8A59F"/>
+                  <a:srgbClr val="51565D"/>
                 </a:solidFill>
                 <a:latin typeface="Verdana"/>
               </a:rPr>
@@ -4776,6 +4798,11 @@
           <a:prstGeom prst="rect">
             <a:avLst/>
           </a:prstGeom>
+          <a:ln w="9525">
+            <a:solidFill>
+              <a:srgbClr val="C8C4BD"/>
+            </a:solidFill>
+          </a:ln>
         </p:spPr>
       </p:pic>
       <p:sp>
@@ -4808,7 +4835,7 @@
             <a:r>
               <a:rPr sz="1000" b="0">
                 <a:solidFill>
-                  <a:srgbClr val="A8A59F"/>
+                  <a:srgbClr val="51565D"/>
                 </a:solidFill>
                 <a:latin typeface="Verdana"/>
               </a:rPr>
@@ -4839,6 +4866,11 @@
           <a:prstGeom prst="rect">
             <a:avLst/>
           </a:prstGeom>
+          <a:ln w="9525">
+            <a:solidFill>
+              <a:srgbClr val="C8C4BD"/>
+            </a:solidFill>
+          </a:ln>
         </p:spPr>
       </p:pic>
       <p:sp>
@@ -4871,7 +4903,7 @@
             <a:r>
               <a:rPr sz="1000" b="0">
                 <a:solidFill>
-                  <a:srgbClr val="A8A59F"/>
+                  <a:srgbClr val="51565D"/>
                 </a:solidFill>
                 <a:latin typeface="Verdana"/>
               </a:rPr>
@@ -4902,6 +4934,11 @@
           <a:prstGeom prst="rect">
             <a:avLst/>
           </a:prstGeom>
+          <a:ln w="9525">
+            <a:solidFill>
+              <a:srgbClr val="C8C4BD"/>
+            </a:solidFill>
+          </a:ln>
         </p:spPr>
       </p:pic>
       <p:sp>
@@ -4934,7 +4971,7 @@
             <a:r>
               <a:rPr sz="1000" b="0">
                 <a:solidFill>
-                  <a:srgbClr val="A8A59F"/>
+                  <a:srgbClr val="51565D"/>
                 </a:solidFill>
                 <a:latin typeface="Verdana"/>
               </a:rPr>
@@ -4976,7 +5013,7 @@
             <a:avLst/>
           </a:prstGeom>
           <a:solidFill>
-            <a:srgbClr val="0E0F12"/>
+            <a:srgbClr val="FAF9F7"/>
           </a:solidFill>
           <a:ln>
             <a:noFill/>
@@ -5035,7 +5072,7 @@
             <a:r>
               <a:rPr sz="1100" b="1">
                 <a:solidFill>
-                  <a:srgbClr val="FF5A2C"/>
+                  <a:srgbClr val="E04418"/>
                 </a:solidFill>
                 <a:latin typeface="Verdana"/>
               </a:rPr>
@@ -5074,7 +5111,7 @@
             <a:r>
               <a:rPr sz="4000" b="1">
                 <a:solidFill>
-                  <a:srgbClr val="F5F2EC"/>
+                  <a:srgbClr val="14161A"/>
                 </a:solidFill>
                 <a:latin typeface="Verdana"/>
               </a:rPr>
@@ -5100,10 +5137,12 @@
             </a:avLst>
           </a:prstGeom>
           <a:solidFill>
-            <a:srgbClr val="1B1C21"/>
+            <a:srgbClr val="F0EEEA"/>
           </a:solidFill>
-          <a:ln>
-            <a:noFill/>
+          <a:ln w="12700">
+            <a:solidFill>
+              <a:srgbClr val="DDD9D2"/>
+            </a:solidFill>
           </a:ln>
           <a:effectLst/>
         </p:spPr>
@@ -5159,7 +5198,7 @@
             <a:r>
               <a:rPr sz="1500" b="1">
                 <a:solidFill>
-                  <a:srgbClr val="F5F2EC"/>
+                  <a:srgbClr val="14161A"/>
                 </a:solidFill>
                 <a:latin typeface="Verdana"/>
               </a:rPr>
@@ -5198,7 +5237,7 @@
             <a:r>
               <a:rPr sz="1100" b="0">
                 <a:solidFill>
-                  <a:srgbClr val="A8A59F"/>
+                  <a:srgbClr val="51565D"/>
                 </a:solidFill>
                 <a:latin typeface="Verdana"/>
               </a:rPr>
@@ -5224,10 +5263,12 @@
             </a:avLst>
           </a:prstGeom>
           <a:solidFill>
-            <a:srgbClr val="1B1C21"/>
+            <a:srgbClr val="F0EEEA"/>
           </a:solidFill>
-          <a:ln>
-            <a:noFill/>
+          <a:ln w="12700">
+            <a:solidFill>
+              <a:srgbClr val="DDD9D2"/>
+            </a:solidFill>
           </a:ln>
           <a:effectLst/>
         </p:spPr>
@@ -5283,7 +5324,7 @@
             <a:r>
               <a:rPr sz="1500" b="1">
                 <a:solidFill>
-                  <a:srgbClr val="F5F2EC"/>
+                  <a:srgbClr val="14161A"/>
                 </a:solidFill>
                 <a:latin typeface="Verdana"/>
               </a:rPr>
@@ -5322,7 +5363,7 @@
             <a:r>
               <a:rPr sz="1100" b="0">
                 <a:solidFill>
-                  <a:srgbClr val="A8A59F"/>
+                  <a:srgbClr val="51565D"/>
                 </a:solidFill>
                 <a:latin typeface="Verdana"/>
               </a:rPr>
@@ -5348,10 +5389,12 @@
             </a:avLst>
           </a:prstGeom>
           <a:solidFill>
-            <a:srgbClr val="1B1C21"/>
+            <a:srgbClr val="F0EEEA"/>
           </a:solidFill>
-          <a:ln>
-            <a:noFill/>
+          <a:ln w="12700">
+            <a:solidFill>
+              <a:srgbClr val="DDD9D2"/>
+            </a:solidFill>
           </a:ln>
           <a:effectLst/>
         </p:spPr>
@@ -5407,7 +5450,7 @@
             <a:r>
               <a:rPr sz="1500" b="1">
                 <a:solidFill>
-                  <a:srgbClr val="F5F2EC"/>
+                  <a:srgbClr val="14161A"/>
                 </a:solidFill>
                 <a:latin typeface="Verdana"/>
               </a:rPr>
@@ -5446,7 +5489,7 @@
             <a:r>
               <a:rPr sz="1100" b="0">
                 <a:solidFill>
-                  <a:srgbClr val="A8A59F"/>
+                  <a:srgbClr val="51565D"/>
                 </a:solidFill>
                 <a:latin typeface="Verdana"/>
               </a:rPr>
@@ -5472,10 +5515,12 @@
             </a:avLst>
           </a:prstGeom>
           <a:solidFill>
-            <a:srgbClr val="1B1C21"/>
+            <a:srgbClr val="F0EEEA"/>
           </a:solidFill>
-          <a:ln>
-            <a:noFill/>
+          <a:ln w="12700">
+            <a:solidFill>
+              <a:srgbClr val="DDD9D2"/>
+            </a:solidFill>
           </a:ln>
           <a:effectLst/>
         </p:spPr>
@@ -5531,7 +5576,7 @@
             <a:r>
               <a:rPr sz="1500" b="1">
                 <a:solidFill>
-                  <a:srgbClr val="F5F2EC"/>
+                  <a:srgbClr val="14161A"/>
                 </a:solidFill>
                 <a:latin typeface="Verdana"/>
               </a:rPr>
@@ -5570,7 +5615,7 @@
             <a:r>
               <a:rPr sz="1100" b="0">
                 <a:solidFill>
-                  <a:srgbClr val="A8A59F"/>
+                  <a:srgbClr val="51565D"/>
                 </a:solidFill>
                 <a:latin typeface="Verdana"/>
               </a:rPr>
@@ -5601,6 +5646,11 @@
           <a:prstGeom prst="rect">
             <a:avLst/>
           </a:prstGeom>
+          <a:ln w="9525">
+            <a:solidFill>
+              <a:srgbClr val="C8C4BD"/>
+            </a:solidFill>
+          </a:ln>
         </p:spPr>
       </p:pic>
       <p:sp>
@@ -5633,7 +5683,7 @@
             <a:r>
               <a:rPr sz="1000" b="0">
                 <a:solidFill>
-                  <a:srgbClr val="A8A59F"/>
+                  <a:srgbClr val="51565D"/>
                 </a:solidFill>
                 <a:latin typeface="Verdana"/>
               </a:rPr>
@@ -5675,7 +5725,7 @@
             <a:avLst/>
           </a:prstGeom>
           <a:solidFill>
-            <a:srgbClr val="0E0F12"/>
+            <a:srgbClr val="FAF9F7"/>
           </a:solidFill>
           <a:ln>
             <a:noFill/>
@@ -5734,7 +5784,7 @@
             <a:r>
               <a:rPr sz="1100" b="1">
                 <a:solidFill>
-                  <a:srgbClr val="FF5A2C"/>
+                  <a:srgbClr val="E04418"/>
                 </a:solidFill>
                 <a:latin typeface="Verdana"/>
               </a:rPr>
@@ -5773,7 +5823,7 @@
             <a:r>
               <a:rPr sz="4000" b="1">
                 <a:solidFill>
-                  <a:srgbClr val="F5F2EC"/>
+                  <a:srgbClr val="14161A"/>
                 </a:solidFill>
                 <a:latin typeface="Verdana"/>
               </a:rPr>
@@ -5812,7 +5862,7 @@
             <a:r>
               <a:rPr sz="1500" b="0">
                 <a:solidFill>
-                  <a:srgbClr val="A8A59F"/>
+                  <a:srgbClr val="51565D"/>
                 </a:solidFill>
                 <a:latin typeface="Verdana"/>
               </a:rPr>
@@ -5828,7 +5878,7 @@
             <a:r>
               <a:rPr sz="1500" b="0">
                 <a:solidFill>
-                  <a:srgbClr val="A8A59F"/>
+                  <a:srgbClr val="51565D"/>
                 </a:solidFill>
                 <a:latin typeface="Verdana"/>
               </a:rPr>
@@ -5844,7 +5894,7 @@
             <a:r>
               <a:rPr sz="1500" b="0">
                 <a:solidFill>
-                  <a:srgbClr val="A8A59F"/>
+                  <a:srgbClr val="51565D"/>
                 </a:solidFill>
                 <a:latin typeface="Verdana"/>
               </a:rPr>
@@ -5870,10 +5920,12 @@
             </a:avLst>
           </a:prstGeom>
           <a:solidFill>
-            <a:srgbClr val="1B1C21"/>
+            <a:srgbClr val="F0EEEA"/>
           </a:solidFill>
-          <a:ln>
-            <a:noFill/>
+          <a:ln w="12700">
+            <a:solidFill>
+              <a:srgbClr val="DDD9D2"/>
+            </a:solidFill>
           </a:ln>
           <a:effectLst/>
         </p:spPr>
@@ -5929,7 +5981,7 @@
             <a:r>
               <a:rPr sz="1300" b="1">
                 <a:solidFill>
-                  <a:srgbClr val="5ED28A"/>
+                  <a:srgbClr val="1F7A45"/>
                 </a:solidFill>
                 <a:latin typeface="Verdana"/>
               </a:rPr>
@@ -5968,7 +6020,7 @@
             <a:r>
               <a:rPr sz="1000" b="0">
                 <a:solidFill>
-                  <a:srgbClr val="A8A59F"/>
+                  <a:srgbClr val="51565D"/>
                 </a:solidFill>
                 <a:latin typeface="Verdana"/>
               </a:rPr>
@@ -5994,10 +6046,12 @@
             </a:avLst>
           </a:prstGeom>
           <a:solidFill>
-            <a:srgbClr val="1B1C21"/>
+            <a:srgbClr val="F0EEEA"/>
           </a:solidFill>
-          <a:ln>
-            <a:noFill/>
+          <a:ln w="12700">
+            <a:solidFill>
+              <a:srgbClr val="DDD9D2"/>
+            </a:solidFill>
           </a:ln>
           <a:effectLst/>
         </p:spPr>
@@ -6053,7 +6107,7 @@
             <a:r>
               <a:rPr sz="1300" b="1">
                 <a:solidFill>
-                  <a:srgbClr val="FF5A2C"/>
+                  <a:srgbClr val="E04418"/>
                 </a:solidFill>
                 <a:latin typeface="Verdana"/>
               </a:rPr>
@@ -6092,7 +6146,7 @@
             <a:r>
               <a:rPr sz="1000" b="0">
                 <a:solidFill>
-                  <a:srgbClr val="A8A59F"/>
+                  <a:srgbClr val="51565D"/>
                 </a:solidFill>
                 <a:latin typeface="Verdana"/>
               </a:rPr>
@@ -6118,10 +6172,12 @@
             </a:avLst>
           </a:prstGeom>
           <a:solidFill>
-            <a:srgbClr val="1B1C21"/>
+            <a:srgbClr val="F0EEEA"/>
           </a:solidFill>
-          <a:ln>
-            <a:noFill/>
+          <a:ln w="12700">
+            <a:solidFill>
+              <a:srgbClr val="DDD9D2"/>
+            </a:solidFill>
           </a:ln>
           <a:effectLst/>
         </p:spPr>
@@ -6177,7 +6233,7 @@
             <a:r>
               <a:rPr sz="1300" b="1">
                 <a:solidFill>
-                  <a:srgbClr val="A8A59F"/>
+                  <a:srgbClr val="51565D"/>
                 </a:solidFill>
                 <a:latin typeface="Verdana"/>
               </a:rPr>
@@ -6216,7 +6272,7 @@
             <a:r>
               <a:rPr sz="1000" b="0">
                 <a:solidFill>
-                  <a:srgbClr val="A8A59F"/>
+                  <a:srgbClr val="51565D"/>
                 </a:solidFill>
                 <a:latin typeface="Verdana"/>
               </a:rPr>
@@ -6255,7 +6311,7 @@
             <a:r>
               <a:rPr sz="1300" b="0">
                 <a:solidFill>
-                  <a:srgbClr val="FF5A2C"/>
+                  <a:srgbClr val="E04418"/>
                 </a:solidFill>
                 <a:latin typeface="Verdana"/>
               </a:rPr>
@@ -6286,6 +6342,11 @@
           <a:prstGeom prst="rect">
             <a:avLst/>
           </a:prstGeom>
+          <a:ln w="9525">
+            <a:solidFill>
+              <a:srgbClr val="C8C4BD"/>
+            </a:solidFill>
+          </a:ln>
         </p:spPr>
       </p:pic>
     </p:spTree>
@@ -6321,7 +6382,7 @@
             <a:avLst/>
           </a:prstGeom>
           <a:solidFill>
-            <a:srgbClr val="0E0F12"/>
+            <a:srgbClr val="FAF9F7"/>
           </a:solidFill>
           <a:ln>
             <a:noFill/>
@@ -6380,7 +6441,7 @@
             <a:r>
               <a:rPr sz="1100" b="1">
                 <a:solidFill>
-                  <a:srgbClr val="FF5A2C"/>
+                  <a:srgbClr val="E04418"/>
                 </a:solidFill>
                 <a:latin typeface="Verdana"/>
               </a:rPr>
@@ -6419,7 +6480,7 @@
             <a:r>
               <a:rPr sz="4000" b="1">
                 <a:solidFill>
-                  <a:srgbClr val="F5F2EC"/>
+                  <a:srgbClr val="14161A"/>
                 </a:solidFill>
                 <a:latin typeface="Verdana"/>
               </a:rPr>
@@ -6458,7 +6519,7 @@
             <a:r>
               <a:rPr sz="1500" b="0">
                 <a:solidFill>
-                  <a:srgbClr val="A8A59F"/>
+                  <a:srgbClr val="51565D"/>
                 </a:solidFill>
                 <a:latin typeface="Verdana"/>
               </a:rPr>
@@ -6474,7 +6535,7 @@
             <a:r>
               <a:rPr sz="1500" b="0">
                 <a:solidFill>
-                  <a:srgbClr val="A8A59F"/>
+                  <a:srgbClr val="51565D"/>
                 </a:solidFill>
                 <a:latin typeface="Verdana"/>
               </a:rPr>
@@ -6490,7 +6551,7 @@
             <a:r>
               <a:rPr sz="1500" b="0">
                 <a:solidFill>
-                  <a:srgbClr val="A8A59F"/>
+                  <a:srgbClr val="51565D"/>
                 </a:solidFill>
                 <a:latin typeface="Verdana"/>
               </a:rPr>
@@ -6521,6 +6582,11 @@
           <a:prstGeom prst="rect">
             <a:avLst/>
           </a:prstGeom>
+          <a:ln w="9525">
+            <a:solidFill>
+              <a:srgbClr val="C8C4BD"/>
+            </a:solidFill>
+          </a:ln>
         </p:spPr>
       </p:pic>
       <p:pic>
@@ -6545,6 +6611,11 @@
           <a:prstGeom prst="rect">
             <a:avLst/>
           </a:prstGeom>
+          <a:ln w="9525">
+            <a:solidFill>
+              <a:srgbClr val="C8C4BD"/>
+            </a:solidFill>
+          </a:ln>
         </p:spPr>
       </p:pic>
     </p:spTree>
@@ -6580,7 +6651,7 @@
             <a:avLst/>
           </a:prstGeom>
           <a:solidFill>
-            <a:srgbClr val="0E0F12"/>
+            <a:srgbClr val="FAF9F7"/>
           </a:solidFill>
           <a:ln>
             <a:noFill/>
@@ -6639,7 +6710,7 @@
             <a:r>
               <a:rPr sz="1100" b="1">
                 <a:solidFill>
-                  <a:srgbClr val="FF5A2C"/>
+                  <a:srgbClr val="E04418"/>
                 </a:solidFill>
                 <a:latin typeface="Verdana"/>
               </a:rPr>
@@ -6678,7 +6749,7 @@
             <a:r>
               <a:rPr sz="3800" b="1">
                 <a:solidFill>
-                  <a:srgbClr val="F5F2EC"/>
+                  <a:srgbClr val="14161A"/>
                 </a:solidFill>
                 <a:latin typeface="Verdana"/>
               </a:rPr>
@@ -6704,10 +6775,12 @@
             </a:avLst>
           </a:prstGeom>
           <a:solidFill>
-            <a:srgbClr val="24262C"/>
+            <a:srgbClr val="E4E1DB"/>
           </a:solidFill>
-          <a:ln>
-            <a:noFill/>
+          <a:ln w="12700">
+            <a:solidFill>
+              <a:srgbClr val="DDD9D2"/>
+            </a:solidFill>
           </a:ln>
           <a:effectLst/>
         </p:spPr>
@@ -6763,7 +6836,7 @@
             <a:r>
               <a:rPr sz="1300" b="0">
                 <a:solidFill>
-                  <a:srgbClr val="777571"/>
+                  <a:srgbClr val="7C8188"/>
                 </a:solidFill>
                 <a:latin typeface="Verdana"/>
               </a:rPr>
@@ -6779,7 +6852,7 @@
             <a:r>
               <a:rPr sz="1300" b="0">
                 <a:solidFill>
-                  <a:srgbClr val="777571"/>
+                  <a:srgbClr val="7C8188"/>
                 </a:solidFill>
                 <a:latin typeface="Verdana"/>
               </a:rPr>
@@ -6818,7 +6891,7 @@
             <a:r>
               <a:rPr sz="1100" b="0">
                 <a:solidFill>
-                  <a:srgbClr val="A8A59F"/>
+                  <a:srgbClr val="51565D"/>
                 </a:solidFill>
                 <a:latin typeface="Verdana"/>
               </a:rPr>
@@ -6844,10 +6917,12 @@
             </a:avLst>
           </a:prstGeom>
           <a:solidFill>
-            <a:srgbClr val="24262C"/>
+            <a:srgbClr val="E4E1DB"/>
           </a:solidFill>
-          <a:ln>
-            <a:noFill/>
+          <a:ln w="12700">
+            <a:solidFill>
+              <a:srgbClr val="DDD9D2"/>
+            </a:solidFill>
           </a:ln>
           <a:effectLst/>
         </p:spPr>
@@ -6903,7 +6978,7 @@
             <a:r>
               <a:rPr sz="1300" b="0">
                 <a:solidFill>
-                  <a:srgbClr val="777571"/>
+                  <a:srgbClr val="7C8188"/>
                 </a:solidFill>
                 <a:latin typeface="Verdana"/>
               </a:rPr>
@@ -6919,7 +6994,7 @@
             <a:r>
               <a:rPr sz="1300" b="0">
                 <a:solidFill>
-                  <a:srgbClr val="777571"/>
+                  <a:srgbClr val="7C8188"/>
                 </a:solidFill>
                 <a:latin typeface="Verdana"/>
               </a:rPr>
@@ -6958,7 +7033,7 @@
             <a:r>
               <a:rPr sz="1100" b="0">
                 <a:solidFill>
-                  <a:srgbClr val="A8A59F"/>
+                  <a:srgbClr val="51565D"/>
                 </a:solidFill>
                 <a:latin typeface="Verdana"/>
               </a:rPr>
@@ -7000,7 +7075,7 @@
             <a:avLst/>
           </a:prstGeom>
           <a:solidFill>
-            <a:srgbClr val="0E0F12"/>
+            <a:srgbClr val="FAF9F7"/>
           </a:solidFill>
           <a:ln>
             <a:noFill/>
@@ -7059,7 +7134,7 @@
             <a:r>
               <a:rPr sz="1100" b="1">
                 <a:solidFill>
-                  <a:srgbClr val="FF5A2C"/>
+                  <a:srgbClr val="E04418"/>
                 </a:solidFill>
                 <a:latin typeface="Verdana"/>
               </a:rPr>
@@ -7098,7 +7173,7 @@
             <a:r>
               <a:rPr sz="3800" b="1">
                 <a:solidFill>
-                  <a:srgbClr val="F5F2EC"/>
+                  <a:srgbClr val="14161A"/>
                 </a:solidFill>
                 <a:latin typeface="Verdana"/>
               </a:rPr>
@@ -7124,10 +7199,12 @@
             </a:avLst>
           </a:prstGeom>
           <a:solidFill>
-            <a:srgbClr val="24262C"/>
+            <a:srgbClr val="E4E1DB"/>
           </a:solidFill>
-          <a:ln>
-            <a:noFill/>
+          <a:ln w="12700">
+            <a:solidFill>
+              <a:srgbClr val="DDD9D2"/>
+            </a:solidFill>
           </a:ln>
           <a:effectLst/>
         </p:spPr>
@@ -7183,7 +7260,7 @@
             <a:r>
               <a:rPr sz="1300" b="0">
                 <a:solidFill>
-                  <a:srgbClr val="777571"/>
+                  <a:srgbClr val="7C8188"/>
                 </a:solidFill>
                 <a:latin typeface="Verdana"/>
               </a:rPr>
@@ -7199,7 +7276,7 @@
             <a:r>
               <a:rPr sz="1300" b="0">
                 <a:solidFill>
-                  <a:srgbClr val="777571"/>
+                  <a:srgbClr val="7C8188"/>
                 </a:solidFill>
                 <a:latin typeface="Verdana"/>
               </a:rPr>
@@ -7238,7 +7315,7 @@
             <a:r>
               <a:rPr sz="1100" b="0">
                 <a:solidFill>
-                  <a:srgbClr val="A8A59F"/>
+                  <a:srgbClr val="51565D"/>
                 </a:solidFill>
                 <a:latin typeface="Verdana"/>
               </a:rPr>
@@ -7277,7 +7354,7 @@
             <a:r>
               <a:rPr sz="1500" b="0">
                 <a:solidFill>
-                  <a:srgbClr val="A8A59F"/>
+                  <a:srgbClr val="51565D"/>
                 </a:solidFill>
                 <a:latin typeface="Verdana"/>
               </a:rPr>
@@ -7293,7 +7370,7 @@
             <a:r>
               <a:rPr sz="1500" b="0">
                 <a:solidFill>
-                  <a:srgbClr val="A8A59F"/>
+                  <a:srgbClr val="51565D"/>
                 </a:solidFill>
                 <a:latin typeface="Verdana"/>
               </a:rPr>
@@ -7309,7 +7386,7 @@
             <a:r>
               <a:rPr sz="1500" b="0">
                 <a:solidFill>
-                  <a:srgbClr val="A8A59F"/>
+                  <a:srgbClr val="51565D"/>
                 </a:solidFill>
                 <a:latin typeface="Verdana"/>
               </a:rPr>
@@ -7325,7 +7402,7 @@
             <a:r>
               <a:rPr sz="1500" b="0">
                 <a:solidFill>
-                  <a:srgbClr val="A8A59F"/>
+                  <a:srgbClr val="51565D"/>
                 </a:solidFill>
                 <a:latin typeface="Verdana"/>
               </a:rPr>
@@ -7341,7 +7418,7 @@
             <a:r>
               <a:rPr sz="1500" b="0">
                 <a:solidFill>
-                  <a:srgbClr val="A8A59F"/>
+                  <a:srgbClr val="51565D"/>
                 </a:solidFill>
                 <a:latin typeface="Verdana"/>
               </a:rPr>
@@ -7357,7 +7434,7 @@
             <a:r>
               <a:rPr sz="1500" b="0">
                 <a:solidFill>
-                  <a:srgbClr val="A8A59F"/>
+                  <a:srgbClr val="51565D"/>
                 </a:solidFill>
                 <a:latin typeface="Verdana"/>
               </a:rPr>
@@ -7373,7 +7450,7 @@
             <a:r>
               <a:rPr sz="1500" b="0">
                 <a:solidFill>
-                  <a:srgbClr val="A8A59F"/>
+                  <a:srgbClr val="51565D"/>
                 </a:solidFill>
                 <a:latin typeface="Verdana"/>
               </a:rPr>
@@ -7415,7 +7492,7 @@
             <a:avLst/>
           </a:prstGeom>
           <a:solidFill>
-            <a:srgbClr val="0E0F12"/>
+            <a:srgbClr val="FAF9F7"/>
           </a:solidFill>
           <a:ln>
             <a:noFill/>
@@ -7474,7 +7551,7 @@
             <a:r>
               <a:rPr sz="1100" b="1">
                 <a:solidFill>
-                  <a:srgbClr val="FF5A2C"/>
+                  <a:srgbClr val="E04418"/>
                 </a:solidFill>
                 <a:latin typeface="Verdana"/>
               </a:rPr>
@@ -7513,7 +7590,7 @@
             <a:r>
               <a:rPr sz="4000" b="1">
                 <a:solidFill>
-                  <a:srgbClr val="F5F2EC"/>
+                  <a:srgbClr val="14161A"/>
                 </a:solidFill>
                 <a:latin typeface="Verdana"/>
               </a:rPr>
@@ -7552,7 +7629,7 @@
             <a:r>
               <a:rPr sz="4000" b="1">
                 <a:solidFill>
-                  <a:srgbClr val="FF5A2C"/>
+                  <a:srgbClr val="E04418"/>
                 </a:solidFill>
                 <a:latin typeface="Verdana"/>
               </a:rPr>
@@ -7591,7 +7668,7 @@
             <a:r>
               <a:rPr sz="1000" b="0">
                 <a:solidFill>
-                  <a:srgbClr val="A8A59F"/>
+                  <a:srgbClr val="51565D"/>
                 </a:solidFill>
                 <a:latin typeface="Verdana"/>
               </a:rPr>
@@ -7630,7 +7707,7 @@
             <a:r>
               <a:rPr sz="4000" b="1">
                 <a:solidFill>
-                  <a:srgbClr val="FF5A2C"/>
+                  <a:srgbClr val="E04418"/>
                 </a:solidFill>
                 <a:latin typeface="Verdana"/>
               </a:rPr>
@@ -7669,7 +7746,7 @@
             <a:r>
               <a:rPr sz="1000" b="0">
                 <a:solidFill>
-                  <a:srgbClr val="A8A59F"/>
+                  <a:srgbClr val="51565D"/>
                 </a:solidFill>
                 <a:latin typeface="Verdana"/>
               </a:rPr>
@@ -7708,7 +7785,7 @@
             <a:r>
               <a:rPr sz="4000" b="1">
                 <a:solidFill>
-                  <a:srgbClr val="FF5A2C"/>
+                  <a:srgbClr val="E04418"/>
                 </a:solidFill>
                 <a:latin typeface="Verdana"/>
               </a:rPr>
@@ -7747,7 +7824,7 @@
             <a:r>
               <a:rPr sz="1000" b="0">
                 <a:solidFill>
-                  <a:srgbClr val="A8A59F"/>
+                  <a:srgbClr val="51565D"/>
                 </a:solidFill>
                 <a:latin typeface="Verdana"/>
               </a:rPr>
@@ -7786,7 +7863,7 @@
             <a:r>
               <a:rPr sz="4000" b="1">
                 <a:solidFill>
-                  <a:srgbClr val="FF5A2C"/>
+                  <a:srgbClr val="E04418"/>
                 </a:solidFill>
                 <a:latin typeface="Verdana"/>
               </a:rPr>
@@ -7825,7 +7902,7 @@
             <a:r>
               <a:rPr sz="1000" b="0">
                 <a:solidFill>
-                  <a:srgbClr val="A8A59F"/>
+                  <a:srgbClr val="51565D"/>
                 </a:solidFill>
                 <a:latin typeface="Verdana"/>
               </a:rPr>
@@ -7864,7 +7941,7 @@
             <a:r>
               <a:rPr sz="4000" b="1">
                 <a:solidFill>
-                  <a:srgbClr val="FF5A2C"/>
+                  <a:srgbClr val="E04418"/>
                 </a:solidFill>
                 <a:latin typeface="Verdana"/>
               </a:rPr>
@@ -7903,7 +7980,7 @@
             <a:r>
               <a:rPr sz="1000" b="0">
                 <a:solidFill>
-                  <a:srgbClr val="A8A59F"/>
+                  <a:srgbClr val="51565D"/>
                 </a:solidFill>
                 <a:latin typeface="Verdana"/>
               </a:rPr>
@@ -7942,7 +8019,7 @@
             <a:r>
               <a:rPr sz="1400" b="0">
                 <a:solidFill>
-                  <a:srgbClr val="FF5A2C"/>
+                  <a:srgbClr val="E04418"/>
                 </a:solidFill>
                 <a:latin typeface="Verdana"/>
               </a:rPr>
@@ -7968,10 +8045,12 @@
             </a:avLst>
           </a:prstGeom>
           <a:solidFill>
-            <a:srgbClr val="1B1C21"/>
+            <a:srgbClr val="F0EEEA"/>
           </a:solidFill>
-          <a:ln>
-            <a:noFill/>
+          <a:ln w="12700">
+            <a:solidFill>
+              <a:srgbClr val="DDD9D2"/>
+            </a:solidFill>
           </a:ln>
           <a:effectLst/>
         </p:spPr>
@@ -8027,7 +8106,7 @@
             <a:r>
               <a:rPr sz="1300" b="1">
                 <a:solidFill>
-                  <a:srgbClr val="F5F2EC"/>
+                  <a:srgbClr val="14161A"/>
                 </a:solidFill>
                 <a:latin typeface="Verdana"/>
               </a:rPr>
@@ -8066,7 +8145,7 @@
             <a:r>
               <a:rPr sz="1100" b="0">
                 <a:solidFill>
-                  <a:srgbClr val="A8A59F"/>
+                  <a:srgbClr val="51565D"/>
                 </a:solidFill>
                 <a:latin typeface="Verdana"/>
               </a:rPr>
@@ -8092,10 +8171,12 @@
             </a:avLst>
           </a:prstGeom>
           <a:solidFill>
-            <a:srgbClr val="1B1C21"/>
+            <a:srgbClr val="F0EEEA"/>
           </a:solidFill>
-          <a:ln>
-            <a:noFill/>
+          <a:ln w="12700">
+            <a:solidFill>
+              <a:srgbClr val="DDD9D2"/>
+            </a:solidFill>
           </a:ln>
           <a:effectLst/>
         </p:spPr>
@@ -8151,7 +8232,7 @@
             <a:r>
               <a:rPr sz="1300" b="1">
                 <a:solidFill>
-                  <a:srgbClr val="F5F2EC"/>
+                  <a:srgbClr val="14161A"/>
                 </a:solidFill>
                 <a:latin typeface="Verdana"/>
               </a:rPr>
@@ -8190,7 +8271,7 @@
             <a:r>
               <a:rPr sz="1100" b="0">
                 <a:solidFill>
-                  <a:srgbClr val="A8A59F"/>
+                  <a:srgbClr val="51565D"/>
                 </a:solidFill>
                 <a:latin typeface="Verdana"/>
               </a:rPr>
@@ -8216,10 +8297,12 @@
             </a:avLst>
           </a:prstGeom>
           <a:solidFill>
-            <a:srgbClr val="1B1C21"/>
+            <a:srgbClr val="F0EEEA"/>
           </a:solidFill>
-          <a:ln>
-            <a:noFill/>
+          <a:ln w="12700">
+            <a:solidFill>
+              <a:srgbClr val="DDD9D2"/>
+            </a:solidFill>
           </a:ln>
           <a:effectLst/>
         </p:spPr>
@@ -8275,7 +8358,7 @@
             <a:r>
               <a:rPr sz="1300" b="1">
                 <a:solidFill>
-                  <a:srgbClr val="F5F2EC"/>
+                  <a:srgbClr val="14161A"/>
                 </a:solidFill>
                 <a:latin typeface="Verdana"/>
               </a:rPr>
@@ -8314,7 +8397,7 @@
             <a:r>
               <a:rPr sz="1100" b="0">
                 <a:solidFill>
-                  <a:srgbClr val="A8A59F"/>
+                  <a:srgbClr val="51565D"/>
                 </a:solidFill>
                 <a:latin typeface="Verdana"/>
               </a:rPr>

</xml_diff>

<commit_message>
fix: the credit line was too faint to read off a projector
The footer on the title slide was carrying the faintest grey in the palette,
which cleared 4.5:1 and nothing more. That standard is written for text read at
arm's length; this is a hall with a projector at the back of it, and it was the
one line on the deck naming the people who built the thing.

It moves to the body grey at 7.9:1, and the faintest grey itself goes from 4.6:1
to 5.8:1 — the only thing still using it is a placeholder that a video replaces.
</commit_message>
<xml_diff>
--- a/ClashFit.pptx
+++ b/ClashFit.pptx
@@ -3318,9 +3318,9 @@
               </a:lnSpc>
             </a:pPr>
             <a:r>
-              <a:rPr sz="1100" b="0">
-                <a:solidFill>
-                  <a:srgbClr val="7C8188"/>
+              <a:rPr sz="1200" b="0">
+                <a:solidFill>
+                  <a:srgbClr val="51565D"/>
                 </a:solidFill>
                 <a:latin typeface="Verdana"/>
               </a:rPr>
@@ -6836,7 +6836,7 @@
             <a:r>
               <a:rPr sz="1300" b="0">
                 <a:solidFill>
-                  <a:srgbClr val="7C8188"/>
+                  <a:srgbClr val="6E737A"/>
                 </a:solidFill>
                 <a:latin typeface="Verdana"/>
               </a:rPr>
@@ -6852,7 +6852,7 @@
             <a:r>
               <a:rPr sz="1300" b="0">
                 <a:solidFill>
-                  <a:srgbClr val="7C8188"/>
+                  <a:srgbClr val="6E737A"/>
                 </a:solidFill>
                 <a:latin typeface="Verdana"/>
               </a:rPr>
@@ -6978,7 +6978,7 @@
             <a:r>
               <a:rPr sz="1300" b="0">
                 <a:solidFill>
-                  <a:srgbClr val="7C8188"/>
+                  <a:srgbClr val="6E737A"/>
                 </a:solidFill>
                 <a:latin typeface="Verdana"/>
               </a:rPr>
@@ -6994,7 +6994,7 @@
             <a:r>
               <a:rPr sz="1300" b="0">
                 <a:solidFill>
-                  <a:srgbClr val="7C8188"/>
+                  <a:srgbClr val="6E737A"/>
                 </a:solidFill>
                 <a:latin typeface="Verdana"/>
               </a:rPr>
@@ -7260,7 +7260,7 @@
             <a:r>
               <a:rPr sz="1300" b="0">
                 <a:solidFill>
-                  <a:srgbClr val="7C8188"/>
+                  <a:srgbClr val="6E737A"/>
                 </a:solidFill>
                 <a:latin typeface="Verdana"/>
               </a:rPr>
@@ -7276,7 +7276,7 @@
             <a:r>
               <a:rPr sz="1300" b="0">
                 <a:solidFill>
-                  <a:srgbClr val="7C8188"/>
+                  <a:srgbClr val="6E737A"/>
                 </a:solidFill>
                 <a:latin typeface="Verdana"/>
               </a:rPr>

</xml_diff>